<commit_message>
Refresh investor deck with live nyumbasearch.com analytics
- Pull current metrics via Playwright: 336 homes, 219 neighbourhoods, 214 providers
- Label LIVE vs INTERNAL metrics on traction slide with platform snapshot
- Auto-fetch analytics before each deck build; update progress and revenue footnotes

Co-authored-by: da-homi3 <da-homi3@users.noreply.github.com>
</commit_message>
<xml_diff>
--- a/investor-deck/NyumbaSearch_Investor_Deck_August_2026.pptx
+++ b/investor-deck/NyumbaSearch_Investor_Deck_August_2026.pptx
@@ -3950,7 +3950,7 @@
                 <a:ea typeface="Arial" pitchFamily="34" charset="-122"/>
                 <a:cs typeface="Arial" pitchFamily="34" charset="-120"/>
               </a:rPr>
-              <a:t>Illustrative planning scenario based on assumptions; actual results may differ.</a:t>
+              <a:t>Illustrative planning scenario based on assumptions; actual results may differ. Current revenue: not disclosed.</a:t>
             </a:r>
             <a:endParaRPr lang="en-US" sz="700" dirty="0"/>
           </a:p>
@@ -4283,7 +4283,7 @@
                 <a:ea typeface="Arial" pitchFamily="34" charset="-122"/>
                 <a:cs typeface="Arial" pitchFamily="34" charset="-120"/>
               </a:rPr>
-              <a:t>263+ verified homes</a:t>
+              <a:t>336+ verified homes</a:t>
             </a:r>
             <a:endParaRPr lang="en-US" sz="900" dirty="0"/>
           </a:p>
@@ -4301,7 +4301,7 @@
                 <a:ea typeface="Arial" pitchFamily="34" charset="-122"/>
                 <a:cs typeface="Arial" pitchFamily="34" charset="-120"/>
               </a:rPr>
-              <a:t>132+ users / tenants</a:t>
+              <a:t>219+ neighbourhoods</a:t>
             </a:r>
             <a:endParaRPr lang="en-US" sz="900" dirty="0"/>
           </a:p>
@@ -4319,7 +4319,7 @@
                 <a:ea typeface="Arial" pitchFamily="34" charset="-122"/>
                 <a:cs typeface="Arial" pitchFamily="34" charset="-120"/>
               </a:rPr>
-              <a:t>24+ listing accounts</a:t>
+              <a:t>214+ service providers</a:t>
             </a:r>
             <a:endParaRPr lang="en-US" sz="900" dirty="0"/>
           </a:p>
@@ -4337,7 +4337,7 @@
                 <a:ea typeface="Arial" pitchFamily="34" charset="-122"/>
                 <a:cs typeface="Arial" pitchFamily="34" charset="-120"/>
               </a:rPr>
-              <a:t>109+ lead actions</a:t>
+              <a:t>132+ users / tenants</a:t>
             </a:r>
             <a:endParaRPr lang="en-US" sz="900" dirty="0"/>
           </a:p>
@@ -4355,7 +4355,7 @@
                 <a:ea typeface="Arial" pitchFamily="34" charset="-122"/>
                 <a:cs typeface="Arial" pitchFamily="34" charset="-120"/>
               </a:rPr>
-              <a:t>214+ service providers</a:t>
+              <a:t>24+ listing accounts</a:t>
             </a:r>
             <a:endParaRPr lang="en-US" sz="900" dirty="0"/>
           </a:p>
@@ -4373,7 +4373,25 @@
                 <a:ea typeface="Arial" pitchFamily="34" charset="-122"/>
                 <a:cs typeface="Arial" pitchFamily="34" charset="-120"/>
               </a:rPr>
-              <a:t>Live product · early marketplace signal</a:t>
+              <a:t>109+ lead actions</a:t>
+            </a:r>
+            <a:endParaRPr lang="en-US" sz="900" dirty="0"/>
+          </a:p>
+          <a:p>
+            <a:pPr marL="342900" indent="-342900">
+              <a:buSzPct val="100000"/>
+              <a:buChar char="•"/>
+            </a:pPr>
+            <a:r>
+              <a:rPr lang="en-US" sz="900" dirty="0">
+                <a:solidFill>
+                  <a:srgbClr val="5B6C77"/>
+                </a:solidFill>
+                <a:latin typeface="Arial" pitchFamily="34" charset="0"/>
+                <a:ea typeface="Arial" pitchFamily="34" charset="-122"/>
+                <a:cs typeface="Arial" pitchFamily="34" charset="-120"/>
+              </a:rPr>
+              <a:t>Live product · manager portal · services marketplace</a:t>
             </a:r>
             <a:endParaRPr lang="en-US" sz="900" dirty="0"/>
           </a:p>
@@ -4629,7 +4647,7 @@
                 <a:ea typeface="Arial" pitchFamily="34" charset="-122"/>
                 <a:cs typeface="Arial" pitchFamily="34" charset="-120"/>
               </a:rPr>
-              <a:t>High monthly transaction volume</a:t>
+              <a:t>USD 4.8M illustrative annual revenue</a:t>
             </a:r>
             <a:endParaRPr lang="en-US" sz="900" dirty="0"/>
           </a:p>
@@ -4647,7 +4665,7 @@
                 <a:ea typeface="Arial" pitchFamily="34" charset="-122"/>
                 <a:cs typeface="Arial" pitchFamily="34" charset="-120"/>
               </a:rPr>
-              <a:t>Regional expansion</a:t>
+              <a:t>Regional expansion across Africa</a:t>
             </a:r>
             <a:endParaRPr lang="en-US" sz="900" dirty="0"/>
           </a:p>
@@ -17044,7 +17062,7 @@
                 <a:ea typeface="Arial" pitchFamily="34" charset="-122"/>
                 <a:cs typeface="Arial" pitchFamily="34" charset="-120"/>
               </a:rPr>
-              <a:t>TRACTION</a:t>
+              <a:t>TRACTION &amp; CURRENT ANALYTICS</a:t>
             </a:r>
             <a:endParaRPr lang="en-US" sz="900" dirty="0"/>
           </a:p>
@@ -17097,12 +17115,12 @@
         </p:nvSpPr>
         <p:spPr>
           <a:xfrm>
-            <a:off x="502920" y="1325880"/>
-            <a:ext cx="2606040" cy="1051560"/>
+            <a:off x="502920" y="1298448"/>
+            <a:ext cx="2606040" cy="1024128"/>
           </a:xfrm>
           <a:prstGeom prst="roundRect">
             <a:avLst>
-              <a:gd name="adj" fmla="val 6957"/>
+              <a:gd name="adj" fmla="val 7143"/>
             </a:avLst>
           </a:prstGeom>
           <a:solidFill>
@@ -17124,7 +17142,7 @@
         </p:nvSpPr>
         <p:spPr>
           <a:xfrm>
-            <a:off x="502920" y="1435608"/>
+            <a:off x="502920" y="1408176"/>
             <a:ext cx="2606040" cy="384048"/>
           </a:xfrm>
           <a:prstGeom prst="rect">
@@ -17149,7 +17167,7 @@
                 <a:ea typeface="Arial" pitchFamily="34" charset="-122"/>
                 <a:cs typeface="Arial" pitchFamily="34" charset="-120"/>
               </a:rPr>
-              <a:t>263+</a:t>
+              <a:t>336+</a:t>
             </a:r>
             <a:endParaRPr lang="en-US" sz="2600" dirty="0"/>
           </a:p>
@@ -17163,7 +17181,7 @@
         </p:nvSpPr>
         <p:spPr>
           <a:xfrm>
-            <a:off x="502920" y="1801368"/>
+            <a:off x="502920" y="1773936"/>
             <a:ext cx="2606040" cy="320040"/>
           </a:xfrm>
           <a:prstGeom prst="rect">
@@ -17219,12 +17237,73 @@
         </p:nvSpPr>
         <p:spPr>
           <a:xfrm>
-            <a:off x="3291840" y="1325880"/>
-            <a:ext cx="2606040" cy="1051560"/>
+            <a:off x="2194560" y="1371600"/>
+            <a:ext cx="685800" cy="164592"/>
           </a:xfrm>
           <a:prstGeom prst="roundRect">
             <a:avLst>
-              <a:gd name="adj" fmla="val 6957"/>
+              <a:gd name="adj" fmla="val 22222"/>
+            </a:avLst>
+          </a:prstGeom>
+          <a:solidFill>
+            <a:srgbClr val="E1F4E9"/>
+          </a:solidFill>
+          <a:ln/>
+        </p:spPr>
+      </p:sp>
+      <p:sp>
+        <p:nvSpPr>
+          <p:cNvPr id="8" name="Text 6"/>
+          <p:cNvSpPr/>
+          <p:nvPr/>
+        </p:nvSpPr>
+        <p:spPr>
+          <a:xfrm>
+            <a:off x="2194560" y="1380744"/>
+            <a:ext cx="685800" cy="146304"/>
+          </a:xfrm>
+          <a:prstGeom prst="rect">
+            <a:avLst/>
+          </a:prstGeom>
+          <a:noFill/>
+          <a:ln/>
+        </p:spPr>
+        <p:txBody>
+          <a:bodyPr wrap="square" rtlCol="0" anchor="ctr"/>
+          <a:lstStyle/>
+          <a:p>
+            <a:pPr algn="ctr" indent="0" marL="0">
+              <a:buNone/>
+            </a:pPr>
+            <a:r>
+              <a:rPr lang="en-US" sz="550" b="1" dirty="0">
+                <a:solidFill>
+                  <a:srgbClr val="19995C"/>
+                </a:solidFill>
+                <a:latin typeface="Arial" pitchFamily="34" charset="0"/>
+                <a:ea typeface="Arial" pitchFamily="34" charset="-122"/>
+                <a:cs typeface="Arial" pitchFamily="34" charset="-120"/>
+              </a:rPr>
+              <a:t>LIVE</a:t>
+            </a:r>
+            <a:endParaRPr lang="en-US" sz="550" dirty="0"/>
+          </a:p>
+        </p:txBody>
+      </p:sp>
+      <p:sp>
+        <p:nvSpPr>
+          <p:cNvPr id="9" name="Shape 7"/>
+          <p:cNvSpPr/>
+          <p:nvPr/>
+        </p:nvSpPr>
+        <p:spPr>
+          <a:xfrm>
+            <a:off x="3291840" y="1298448"/>
+            <a:ext cx="2606040" cy="1024128"/>
+          </a:xfrm>
+          <a:prstGeom prst="roundRect">
+            <a:avLst>
+              <a:gd name="adj" fmla="val 7143"/>
             </a:avLst>
           </a:prstGeom>
           <a:solidFill>
@@ -17240,13 +17319,13 @@
       </p:sp>
       <p:sp>
         <p:nvSpPr>
-          <p:cNvPr id="8" name="Text 6"/>
-          <p:cNvSpPr/>
-          <p:nvPr/>
-        </p:nvSpPr>
-        <p:spPr>
-          <a:xfrm>
-            <a:off x="3291840" y="1435608"/>
+          <p:cNvPr id="10" name="Text 8"/>
+          <p:cNvSpPr/>
+          <p:nvPr/>
+        </p:nvSpPr>
+        <p:spPr>
+          <a:xfrm>
+            <a:off x="3291840" y="1408176"/>
             <a:ext cx="2606040" cy="384048"/>
           </a:xfrm>
           <a:prstGeom prst="rect">
@@ -17271,7 +17350,7 @@
                 <a:ea typeface="Arial" pitchFamily="34" charset="-122"/>
                 <a:cs typeface="Arial" pitchFamily="34" charset="-120"/>
               </a:rPr>
-              <a:t>182+</a:t>
+              <a:t>219+</a:t>
             </a:r>
             <a:endParaRPr lang="en-US" sz="2600" dirty="0"/>
           </a:p>
@@ -17279,13 +17358,13 @@
       </p:sp>
       <p:sp>
         <p:nvSpPr>
-          <p:cNvPr id="9" name="Text 7"/>
-          <p:cNvSpPr/>
-          <p:nvPr/>
-        </p:nvSpPr>
-        <p:spPr>
-          <a:xfrm>
-            <a:off x="3291840" y="1801368"/>
+          <p:cNvPr id="11" name="Text 9"/>
+          <p:cNvSpPr/>
+          <p:nvPr/>
+        </p:nvSpPr>
+        <p:spPr>
+          <a:xfrm>
+            <a:off x="3291840" y="1773936"/>
             <a:ext cx="2606040" cy="320040"/>
           </a:xfrm>
           <a:prstGeom prst="rect">
@@ -17335,18 +17414,79 @@
       </p:sp>
       <p:sp>
         <p:nvSpPr>
-          <p:cNvPr id="10" name="Shape 8"/>
-          <p:cNvSpPr/>
-          <p:nvPr/>
-        </p:nvSpPr>
-        <p:spPr>
-          <a:xfrm>
-            <a:off x="6080760" y="1325880"/>
-            <a:ext cx="2606040" cy="1051560"/>
+          <p:cNvPr id="12" name="Shape 10"/>
+          <p:cNvSpPr/>
+          <p:nvPr/>
+        </p:nvSpPr>
+        <p:spPr>
+          <a:xfrm>
+            <a:off x="4983480" y="1371600"/>
+            <a:ext cx="685800" cy="164592"/>
           </a:xfrm>
           <a:prstGeom prst="roundRect">
             <a:avLst>
-              <a:gd name="adj" fmla="val 6957"/>
+              <a:gd name="adj" fmla="val 22222"/>
+            </a:avLst>
+          </a:prstGeom>
+          <a:solidFill>
+            <a:srgbClr val="E1F4E9"/>
+          </a:solidFill>
+          <a:ln/>
+        </p:spPr>
+      </p:sp>
+      <p:sp>
+        <p:nvSpPr>
+          <p:cNvPr id="13" name="Text 11"/>
+          <p:cNvSpPr/>
+          <p:nvPr/>
+        </p:nvSpPr>
+        <p:spPr>
+          <a:xfrm>
+            <a:off x="4983480" y="1380744"/>
+            <a:ext cx="685800" cy="146304"/>
+          </a:xfrm>
+          <a:prstGeom prst="rect">
+            <a:avLst/>
+          </a:prstGeom>
+          <a:noFill/>
+          <a:ln/>
+        </p:spPr>
+        <p:txBody>
+          <a:bodyPr wrap="square" rtlCol="0" anchor="ctr"/>
+          <a:lstStyle/>
+          <a:p>
+            <a:pPr algn="ctr" indent="0" marL="0">
+              <a:buNone/>
+            </a:pPr>
+            <a:r>
+              <a:rPr lang="en-US" sz="550" b="1" dirty="0">
+                <a:solidFill>
+                  <a:srgbClr val="19995C"/>
+                </a:solidFill>
+                <a:latin typeface="Arial" pitchFamily="34" charset="0"/>
+                <a:ea typeface="Arial" pitchFamily="34" charset="-122"/>
+                <a:cs typeface="Arial" pitchFamily="34" charset="-120"/>
+              </a:rPr>
+              <a:t>LIVE</a:t>
+            </a:r>
+            <a:endParaRPr lang="en-US" sz="550" dirty="0"/>
+          </a:p>
+        </p:txBody>
+      </p:sp>
+      <p:sp>
+        <p:nvSpPr>
+          <p:cNvPr id="14" name="Shape 12"/>
+          <p:cNvSpPr/>
+          <p:nvPr/>
+        </p:nvSpPr>
+        <p:spPr>
+          <a:xfrm>
+            <a:off x="6080760" y="1298448"/>
+            <a:ext cx="2606040" cy="1024128"/>
+          </a:xfrm>
+          <a:prstGeom prst="roundRect">
+            <a:avLst>
+              <a:gd name="adj" fmla="val 7143"/>
             </a:avLst>
           </a:prstGeom>
           <a:solidFill>
@@ -17362,13 +17502,13 @@
       </p:sp>
       <p:sp>
         <p:nvSpPr>
-          <p:cNvPr id="11" name="Text 9"/>
-          <p:cNvSpPr/>
-          <p:nvPr/>
-        </p:nvSpPr>
-        <p:spPr>
-          <a:xfrm>
-            <a:off x="6080760" y="1435608"/>
+          <p:cNvPr id="15" name="Text 13"/>
+          <p:cNvSpPr/>
+          <p:nvPr/>
+        </p:nvSpPr>
+        <p:spPr>
+          <a:xfrm>
+            <a:off x="6080760" y="1408176"/>
             <a:ext cx="2606040" cy="384048"/>
           </a:xfrm>
           <a:prstGeom prst="rect">
@@ -17401,13 +17541,13 @@
       </p:sp>
       <p:sp>
         <p:nvSpPr>
-          <p:cNvPr id="12" name="Text 10"/>
-          <p:cNvSpPr/>
-          <p:nvPr/>
-        </p:nvSpPr>
-        <p:spPr>
-          <a:xfrm>
-            <a:off x="6080760" y="1801368"/>
+          <p:cNvPr id="16" name="Text 14"/>
+          <p:cNvSpPr/>
+          <p:nvPr/>
+        </p:nvSpPr>
+        <p:spPr>
+          <a:xfrm>
+            <a:off x="6080760" y="1773936"/>
             <a:ext cx="2606040" cy="320040"/>
           </a:xfrm>
           <a:prstGeom prst="rect">
@@ -17457,18 +17597,79 @@
       </p:sp>
       <p:sp>
         <p:nvSpPr>
-          <p:cNvPr id="13" name="Shape 11"/>
-          <p:cNvSpPr/>
-          <p:nvPr/>
-        </p:nvSpPr>
-        <p:spPr>
-          <a:xfrm>
-            <a:off x="502920" y="2560320"/>
-            <a:ext cx="2606040" cy="1051560"/>
+          <p:cNvPr id="17" name="Shape 15"/>
+          <p:cNvSpPr/>
+          <p:nvPr/>
+        </p:nvSpPr>
+        <p:spPr>
+          <a:xfrm>
+            <a:off x="7772400" y="1371600"/>
+            <a:ext cx="685800" cy="164592"/>
           </a:xfrm>
           <a:prstGeom prst="roundRect">
             <a:avLst>
-              <a:gd name="adj" fmla="val 6957"/>
+              <a:gd name="adj" fmla="val 22222"/>
+            </a:avLst>
+          </a:prstGeom>
+          <a:solidFill>
+            <a:srgbClr val="E1F4E9"/>
+          </a:solidFill>
+          <a:ln/>
+        </p:spPr>
+      </p:sp>
+      <p:sp>
+        <p:nvSpPr>
+          <p:cNvPr id="18" name="Text 16"/>
+          <p:cNvSpPr/>
+          <p:nvPr/>
+        </p:nvSpPr>
+        <p:spPr>
+          <a:xfrm>
+            <a:off x="7772400" y="1380744"/>
+            <a:ext cx="685800" cy="146304"/>
+          </a:xfrm>
+          <a:prstGeom prst="rect">
+            <a:avLst/>
+          </a:prstGeom>
+          <a:noFill/>
+          <a:ln/>
+        </p:spPr>
+        <p:txBody>
+          <a:bodyPr wrap="square" rtlCol="0" anchor="ctr"/>
+          <a:lstStyle/>
+          <a:p>
+            <a:pPr algn="ctr" indent="0" marL="0">
+              <a:buNone/>
+            </a:pPr>
+            <a:r>
+              <a:rPr lang="en-US" sz="550" b="1" dirty="0">
+                <a:solidFill>
+                  <a:srgbClr val="19995C"/>
+                </a:solidFill>
+                <a:latin typeface="Arial" pitchFamily="34" charset="0"/>
+                <a:ea typeface="Arial" pitchFamily="34" charset="-122"/>
+                <a:cs typeface="Arial" pitchFamily="34" charset="-120"/>
+              </a:rPr>
+              <a:t>LIVE</a:t>
+            </a:r>
+            <a:endParaRPr lang="en-US" sz="550" dirty="0"/>
+          </a:p>
+        </p:txBody>
+      </p:sp>
+      <p:sp>
+        <p:nvSpPr>
+          <p:cNvPr id="19" name="Shape 17"/>
+          <p:cNvSpPr/>
+          <p:nvPr/>
+        </p:nvSpPr>
+        <p:spPr>
+          <a:xfrm>
+            <a:off x="502920" y="2505456"/>
+            <a:ext cx="2606040" cy="1024128"/>
+          </a:xfrm>
+          <a:prstGeom prst="roundRect">
+            <a:avLst>
+              <a:gd name="adj" fmla="val 7143"/>
             </a:avLst>
           </a:prstGeom>
           <a:solidFill>
@@ -17484,13 +17685,13 @@
       </p:sp>
       <p:sp>
         <p:nvSpPr>
-          <p:cNvPr id="14" name="Text 12"/>
-          <p:cNvSpPr/>
-          <p:nvPr/>
-        </p:nvSpPr>
-        <p:spPr>
-          <a:xfrm>
-            <a:off x="502920" y="2670048"/>
+          <p:cNvPr id="20" name="Text 18"/>
+          <p:cNvSpPr/>
+          <p:nvPr/>
+        </p:nvSpPr>
+        <p:spPr>
+          <a:xfrm>
+            <a:off x="502920" y="2615184"/>
             <a:ext cx="2606040" cy="384048"/>
           </a:xfrm>
           <a:prstGeom prst="rect">
@@ -17523,13 +17724,13 @@
       </p:sp>
       <p:sp>
         <p:nvSpPr>
-          <p:cNvPr id="15" name="Text 13"/>
-          <p:cNvSpPr/>
-          <p:nvPr/>
-        </p:nvSpPr>
-        <p:spPr>
-          <a:xfrm>
-            <a:off x="502920" y="3035808"/>
+          <p:cNvPr id="21" name="Text 19"/>
+          <p:cNvSpPr/>
+          <p:nvPr/>
+        </p:nvSpPr>
+        <p:spPr>
+          <a:xfrm>
+            <a:off x="502920" y="2980944"/>
             <a:ext cx="2606040" cy="320040"/>
           </a:xfrm>
           <a:prstGeom prst="rect">
@@ -17579,18 +17780,79 @@
       </p:sp>
       <p:sp>
         <p:nvSpPr>
-          <p:cNvPr id="16" name="Shape 14"/>
-          <p:cNvSpPr/>
-          <p:nvPr/>
-        </p:nvSpPr>
-        <p:spPr>
-          <a:xfrm>
-            <a:off x="3291840" y="2560320"/>
-            <a:ext cx="2606040" cy="1051560"/>
+          <p:cNvPr id="22" name="Shape 20"/>
+          <p:cNvSpPr/>
+          <p:nvPr/>
+        </p:nvSpPr>
+        <p:spPr>
+          <a:xfrm>
+            <a:off x="2194560" y="2578608"/>
+            <a:ext cx="685800" cy="164592"/>
           </a:xfrm>
           <a:prstGeom prst="roundRect">
             <a:avLst>
-              <a:gd name="adj" fmla="val 6957"/>
+              <a:gd name="adj" fmla="val 22222"/>
+            </a:avLst>
+          </a:prstGeom>
+          <a:solidFill>
+            <a:srgbClr val="FFF7ED"/>
+          </a:solidFill>
+          <a:ln/>
+        </p:spPr>
+      </p:sp>
+      <p:sp>
+        <p:nvSpPr>
+          <p:cNvPr id="23" name="Text 21"/>
+          <p:cNvSpPr/>
+          <p:nvPr/>
+        </p:nvSpPr>
+        <p:spPr>
+          <a:xfrm>
+            <a:off x="2194560" y="2587752"/>
+            <a:ext cx="685800" cy="146304"/>
+          </a:xfrm>
+          <a:prstGeom prst="rect">
+            <a:avLst/>
+          </a:prstGeom>
+          <a:noFill/>
+          <a:ln/>
+        </p:spPr>
+        <p:txBody>
+          <a:bodyPr wrap="square" rtlCol="0" anchor="ctr"/>
+          <a:lstStyle/>
+          <a:p>
+            <a:pPr algn="ctr" indent="0" marL="0">
+              <a:buNone/>
+            </a:pPr>
+            <a:r>
+              <a:rPr lang="en-US" sz="550" b="1" dirty="0">
+                <a:solidFill>
+                  <a:srgbClr val="E0AA3E"/>
+                </a:solidFill>
+                <a:latin typeface="Arial" pitchFamily="34" charset="0"/>
+                <a:ea typeface="Arial" pitchFamily="34" charset="-122"/>
+                <a:cs typeface="Arial" pitchFamily="34" charset="-120"/>
+              </a:rPr>
+              <a:t>INTERNAL</a:t>
+            </a:r>
+            <a:endParaRPr lang="en-US" sz="550" dirty="0"/>
+          </a:p>
+        </p:txBody>
+      </p:sp>
+      <p:sp>
+        <p:nvSpPr>
+          <p:cNvPr id="24" name="Shape 22"/>
+          <p:cNvSpPr/>
+          <p:nvPr/>
+        </p:nvSpPr>
+        <p:spPr>
+          <a:xfrm>
+            <a:off x="3291840" y="2505456"/>
+            <a:ext cx="2606040" cy="1024128"/>
+          </a:xfrm>
+          <a:prstGeom prst="roundRect">
+            <a:avLst>
+              <a:gd name="adj" fmla="val 7143"/>
             </a:avLst>
           </a:prstGeom>
           <a:solidFill>
@@ -17606,13 +17868,13 @@
       </p:sp>
       <p:sp>
         <p:nvSpPr>
-          <p:cNvPr id="17" name="Text 15"/>
-          <p:cNvSpPr/>
-          <p:nvPr/>
-        </p:nvSpPr>
-        <p:spPr>
-          <a:xfrm>
-            <a:off x="3291840" y="2670048"/>
+          <p:cNvPr id="25" name="Text 23"/>
+          <p:cNvSpPr/>
+          <p:nvPr/>
+        </p:nvSpPr>
+        <p:spPr>
+          <a:xfrm>
+            <a:off x="3291840" y="2615184"/>
             <a:ext cx="2606040" cy="384048"/>
           </a:xfrm>
           <a:prstGeom prst="rect">
@@ -17645,13 +17907,13 @@
       </p:sp>
       <p:sp>
         <p:nvSpPr>
-          <p:cNvPr id="18" name="Text 16"/>
-          <p:cNvSpPr/>
-          <p:nvPr/>
-        </p:nvSpPr>
-        <p:spPr>
-          <a:xfrm>
-            <a:off x="3291840" y="3035808"/>
+          <p:cNvPr id="26" name="Text 24"/>
+          <p:cNvSpPr/>
+          <p:nvPr/>
+        </p:nvSpPr>
+        <p:spPr>
+          <a:xfrm>
+            <a:off x="3291840" y="2980944"/>
             <a:ext cx="2606040" cy="320040"/>
           </a:xfrm>
           <a:prstGeom prst="rect">
@@ -17701,18 +17963,79 @@
       </p:sp>
       <p:sp>
         <p:nvSpPr>
-          <p:cNvPr id="19" name="Shape 17"/>
-          <p:cNvSpPr/>
-          <p:nvPr/>
-        </p:nvSpPr>
-        <p:spPr>
-          <a:xfrm>
-            <a:off x="6080760" y="2560320"/>
-            <a:ext cx="2606040" cy="1051560"/>
+          <p:cNvPr id="27" name="Shape 25"/>
+          <p:cNvSpPr/>
+          <p:nvPr/>
+        </p:nvSpPr>
+        <p:spPr>
+          <a:xfrm>
+            <a:off x="4983480" y="2578608"/>
+            <a:ext cx="685800" cy="164592"/>
           </a:xfrm>
           <a:prstGeom prst="roundRect">
             <a:avLst>
-              <a:gd name="adj" fmla="val 6957"/>
+              <a:gd name="adj" fmla="val 22222"/>
+            </a:avLst>
+          </a:prstGeom>
+          <a:solidFill>
+            <a:srgbClr val="FFF7ED"/>
+          </a:solidFill>
+          <a:ln/>
+        </p:spPr>
+      </p:sp>
+      <p:sp>
+        <p:nvSpPr>
+          <p:cNvPr id="28" name="Text 26"/>
+          <p:cNvSpPr/>
+          <p:nvPr/>
+        </p:nvSpPr>
+        <p:spPr>
+          <a:xfrm>
+            <a:off x="4983480" y="2587752"/>
+            <a:ext cx="685800" cy="146304"/>
+          </a:xfrm>
+          <a:prstGeom prst="rect">
+            <a:avLst/>
+          </a:prstGeom>
+          <a:noFill/>
+          <a:ln/>
+        </p:spPr>
+        <p:txBody>
+          <a:bodyPr wrap="square" rtlCol="0" anchor="ctr"/>
+          <a:lstStyle/>
+          <a:p>
+            <a:pPr algn="ctr" indent="0" marL="0">
+              <a:buNone/>
+            </a:pPr>
+            <a:r>
+              <a:rPr lang="en-US" sz="550" b="1" dirty="0">
+                <a:solidFill>
+                  <a:srgbClr val="E0AA3E"/>
+                </a:solidFill>
+                <a:latin typeface="Arial" pitchFamily="34" charset="0"/>
+                <a:ea typeface="Arial" pitchFamily="34" charset="-122"/>
+                <a:cs typeface="Arial" pitchFamily="34" charset="-120"/>
+              </a:rPr>
+              <a:t>INTERNAL</a:t>
+            </a:r>
+            <a:endParaRPr lang="en-US" sz="550" dirty="0"/>
+          </a:p>
+        </p:txBody>
+      </p:sp>
+      <p:sp>
+        <p:nvSpPr>
+          <p:cNvPr id="29" name="Shape 27"/>
+          <p:cNvSpPr/>
+          <p:nvPr/>
+        </p:nvSpPr>
+        <p:spPr>
+          <a:xfrm>
+            <a:off x="6080760" y="2505456"/>
+            <a:ext cx="2606040" cy="1024128"/>
+          </a:xfrm>
+          <a:prstGeom prst="roundRect">
+            <a:avLst>
+              <a:gd name="adj" fmla="val 7143"/>
             </a:avLst>
           </a:prstGeom>
           <a:solidFill>
@@ -17728,13 +18051,13 @@
       </p:sp>
       <p:sp>
         <p:nvSpPr>
-          <p:cNvPr id="20" name="Text 18"/>
-          <p:cNvSpPr/>
-          <p:nvPr/>
-        </p:nvSpPr>
-        <p:spPr>
-          <a:xfrm>
-            <a:off x="6080760" y="2670048"/>
+          <p:cNvPr id="30" name="Text 28"/>
+          <p:cNvSpPr/>
+          <p:nvPr/>
+        </p:nvSpPr>
+        <p:spPr>
+          <a:xfrm>
+            <a:off x="6080760" y="2615184"/>
             <a:ext cx="2606040" cy="384048"/>
           </a:xfrm>
           <a:prstGeom prst="rect">
@@ -17767,13 +18090,13 @@
       </p:sp>
       <p:sp>
         <p:nvSpPr>
-          <p:cNvPr id="21" name="Text 19"/>
-          <p:cNvSpPr/>
-          <p:nvPr/>
-        </p:nvSpPr>
-        <p:spPr>
-          <a:xfrm>
-            <a:off x="6080760" y="3035808"/>
+          <p:cNvPr id="31" name="Text 29"/>
+          <p:cNvSpPr/>
+          <p:nvPr/>
+        </p:nvSpPr>
+        <p:spPr>
+          <a:xfrm>
+            <a:off x="6080760" y="2980944"/>
             <a:ext cx="2606040" cy="320040"/>
           </a:xfrm>
           <a:prstGeom prst="rect">
@@ -17823,18 +18146,79 @@
       </p:sp>
       <p:sp>
         <p:nvSpPr>
-          <p:cNvPr id="22" name="Shape 20"/>
-          <p:cNvSpPr/>
-          <p:nvPr/>
-        </p:nvSpPr>
-        <p:spPr>
-          <a:xfrm>
-            <a:off x="502920" y="3794760"/>
-            <a:ext cx="5029200" cy="777240"/>
+          <p:cNvPr id="32" name="Shape 30"/>
+          <p:cNvSpPr/>
+          <p:nvPr/>
+        </p:nvSpPr>
+        <p:spPr>
+          <a:xfrm>
+            <a:off x="7772400" y="2578608"/>
+            <a:ext cx="685800" cy="164592"/>
           </a:xfrm>
           <a:prstGeom prst="roundRect">
             <a:avLst>
-              <a:gd name="adj" fmla="val 7059"/>
+              <a:gd name="adj" fmla="val 22222"/>
+            </a:avLst>
+          </a:prstGeom>
+          <a:solidFill>
+            <a:srgbClr val="FFF7ED"/>
+          </a:solidFill>
+          <a:ln/>
+        </p:spPr>
+      </p:sp>
+      <p:sp>
+        <p:nvSpPr>
+          <p:cNvPr id="33" name="Text 31"/>
+          <p:cNvSpPr/>
+          <p:nvPr/>
+        </p:nvSpPr>
+        <p:spPr>
+          <a:xfrm>
+            <a:off x="7772400" y="2587752"/>
+            <a:ext cx="685800" cy="146304"/>
+          </a:xfrm>
+          <a:prstGeom prst="rect">
+            <a:avLst/>
+          </a:prstGeom>
+          <a:noFill/>
+          <a:ln/>
+        </p:spPr>
+        <p:txBody>
+          <a:bodyPr wrap="square" rtlCol="0" anchor="ctr"/>
+          <a:lstStyle/>
+          <a:p>
+            <a:pPr algn="ctr" indent="0" marL="0">
+              <a:buNone/>
+            </a:pPr>
+            <a:r>
+              <a:rPr lang="en-US" sz="550" b="1" dirty="0">
+                <a:solidFill>
+                  <a:srgbClr val="E0AA3E"/>
+                </a:solidFill>
+                <a:latin typeface="Arial" pitchFamily="34" charset="0"/>
+                <a:ea typeface="Arial" pitchFamily="34" charset="-122"/>
+                <a:cs typeface="Arial" pitchFamily="34" charset="-120"/>
+              </a:rPr>
+              <a:t>INTERNAL</a:t>
+            </a:r>
+            <a:endParaRPr lang="en-US" sz="550" dirty="0"/>
+          </a:p>
+        </p:txBody>
+      </p:sp>
+      <p:sp>
+        <p:nvSpPr>
+          <p:cNvPr id="34" name="Shape 32"/>
+          <p:cNvSpPr/>
+          <p:nvPr/>
+        </p:nvSpPr>
+        <p:spPr>
+          <a:xfrm>
+            <a:off x="502920" y="3611880"/>
+            <a:ext cx="5029200" cy="502920"/>
+          </a:xfrm>
+          <a:prstGeom prst="roundRect">
+            <a:avLst>
+              <a:gd name="adj" fmla="val 10909"/>
             </a:avLst>
           </a:prstGeom>
           <a:solidFill>
@@ -17850,14 +18234,53 @@
       </p:sp>
       <p:sp>
         <p:nvSpPr>
-          <p:cNvPr id="23" name="Text 21"/>
+          <p:cNvPr id="35" name="Text 33"/>
+          <p:cNvSpPr/>
+          <p:nvPr/>
+        </p:nvSpPr>
+        <p:spPr>
+          <a:xfrm>
+            <a:off x="640080" y="3657600"/>
+            <a:ext cx="4572000" cy="164592"/>
+          </a:xfrm>
+          <a:prstGeom prst="rect">
+            <a:avLst/>
+          </a:prstGeom>
+          <a:noFill/>
+          <a:ln/>
+        </p:spPr>
+        <p:txBody>
+          <a:bodyPr wrap="square" rtlCol="0" anchor="ctr"/>
+          <a:lstStyle/>
+          <a:p>
+            <a:pPr indent="0" marL="0">
+              <a:buNone/>
+            </a:pPr>
+            <a:r>
+              <a:rPr lang="en-US" sz="800" b="1" dirty="0">
+                <a:solidFill>
+                  <a:srgbClr val="1B2B36"/>
+                </a:solidFill>
+                <a:latin typeface="Arial" pitchFamily="34" charset="0"/>
+                <a:ea typeface="Arial" pitchFamily="34" charset="-122"/>
+                <a:cs typeface="Arial" pitchFamily="34" charset="-120"/>
+              </a:rPr>
+              <a:t>Live platform snapshot (nyumbasearch.com)</a:t>
+            </a:r>
+            <a:endParaRPr lang="en-US" sz="800" dirty="0"/>
+          </a:p>
+        </p:txBody>
+      </p:sp>
+      <p:sp>
+        <p:nvSpPr>
+          <p:cNvPr id="36" name="Text 34"/>
           <p:cNvSpPr/>
           <p:nvPr/>
         </p:nvSpPr>
         <p:spPr>
           <a:xfrm>
             <a:off x="640080" y="3840480"/>
-            <a:ext cx="2743200" cy="182880"/>
+            <a:ext cx="4754880" cy="228600"/>
           </a:xfrm>
           <a:prstGeom prst="rect">
             <a:avLst/>
@@ -17873,30 +18296,69 @@
               <a:buNone/>
             </a:pPr>
             <a:r>
-              <a:rPr lang="en-US" sz="800" b="1" dirty="0">
-                <a:solidFill>
-                  <a:srgbClr val="1B2B36"/>
-                </a:solidFill>
-                <a:latin typeface="Arial" pitchFamily="34" charset="0"/>
-                <a:ea typeface="Arial" pitchFamily="34" charset="-122"/>
-                <a:cs typeface="Arial" pitchFamily="34" charset="-120"/>
-              </a:rPr>
-              <a:t>Operational signal (illustrative)</a:t>
-            </a:r>
-            <a:endParaRPr lang="en-US" sz="800" dirty="0"/>
-          </a:p>
-        </p:txBody>
-      </p:sp>
-      <p:sp>
-        <p:nvSpPr>
-          <p:cNvPr id="24" name="Shape 22"/>
-          <p:cNvSpPr/>
-          <p:nvPr/>
-        </p:nvSpPr>
-        <p:spPr>
-          <a:xfrm>
-            <a:off x="685800" y="4075938"/>
-            <a:ext cx="502920" cy="267462"/>
+              <a:rPr lang="en-US" sz="750" dirty="0">
+                <a:solidFill>
+                  <a:srgbClr val="5B6C77"/>
+                </a:solidFill>
+                <a:latin typeface="Arial" pitchFamily="34" charset="0"/>
+                <a:ea typeface="Arial" pitchFamily="34" charset="-122"/>
+                <a:cs typeface="Arial" pitchFamily="34" charset="-120"/>
+              </a:rPr>
+              <a:t>300+ homes in tenant browse  ·  24+ service categories with providers  ·  336+ indexed property pages</a:t>
+            </a:r>
+            <a:endParaRPr lang="en-US" sz="750" dirty="0"/>
+          </a:p>
+        </p:txBody>
+      </p:sp>
+      <p:sp>
+        <p:nvSpPr>
+          <p:cNvPr id="37" name="Text 35"/>
+          <p:cNvSpPr/>
+          <p:nvPr/>
+        </p:nvSpPr>
+        <p:spPr>
+          <a:xfrm>
+            <a:off x="640080" y="4160520"/>
+            <a:ext cx="2743200" cy="137160"/>
+          </a:xfrm>
+          <a:prstGeom prst="rect">
+            <a:avLst/>
+          </a:prstGeom>
+          <a:noFill/>
+          <a:ln/>
+        </p:spPr>
+        <p:txBody>
+          <a:bodyPr wrap="square" rtlCol="0" anchor="ctr"/>
+          <a:lstStyle/>
+          <a:p>
+            <a:pPr indent="0" marL="0">
+              <a:buNone/>
+            </a:pPr>
+            <a:r>
+              <a:rPr lang="en-US" sz="700" dirty="0">
+                <a:solidFill>
+                  <a:srgbClr val="5B6C77"/>
+                </a:solidFill>
+                <a:latin typeface="Arial" pitchFamily="34" charset="0"/>
+                <a:ea typeface="Arial" pitchFamily="34" charset="-122"/>
+                <a:cs typeface="Arial" pitchFamily="34" charset="-120"/>
+              </a:rPr>
+              <a:t>Relative platform activity</a:t>
+            </a:r>
+            <a:endParaRPr lang="en-US" sz="700" dirty="0"/>
+          </a:p>
+        </p:txBody>
+      </p:sp>
+      <p:sp>
+        <p:nvSpPr>
+          <p:cNvPr id="38" name="Shape 36"/>
+          <p:cNvSpPr/>
+          <p:nvPr/>
+        </p:nvSpPr>
+        <p:spPr>
+          <a:xfrm>
+            <a:off x="685800" y="4142232"/>
+            <a:ext cx="502920" cy="320040"/>
           </a:xfrm>
           <a:prstGeom prst="rect">
             <a:avLst/>
@@ -17909,14 +18371,14 @@
       </p:sp>
       <p:sp>
         <p:nvSpPr>
-          <p:cNvPr id="25" name="Text 23"/>
-          <p:cNvSpPr/>
-          <p:nvPr/>
-        </p:nvSpPr>
-        <p:spPr>
-          <a:xfrm>
-            <a:off x="685800" y="4370832"/>
-            <a:ext cx="502920" cy="137160"/>
+          <p:cNvPr id="39" name="Text 37"/>
+          <p:cNvSpPr/>
+          <p:nvPr/>
+        </p:nvSpPr>
+        <p:spPr>
+          <a:xfrm>
+            <a:off x="685800" y="4480560"/>
+            <a:ext cx="502920" cy="109728"/>
           </a:xfrm>
           <a:prstGeom prst="rect">
             <a:avLst/>
@@ -17932,7 +18394,7 @@
               <a:buNone/>
             </a:pPr>
             <a:r>
-              <a:rPr lang="en-US" sz="650" dirty="0">
+              <a:rPr lang="en-US" sz="600" dirty="0">
                 <a:solidFill>
                   <a:srgbClr val="5B6C77"/>
                 </a:solidFill>
@@ -17942,20 +18404,20 @@
               </a:rPr>
               <a:t>Homes</a:t>
             </a:r>
-            <a:endParaRPr lang="en-US" sz="650" dirty="0"/>
-          </a:p>
-        </p:txBody>
-      </p:sp>
-      <p:sp>
-        <p:nvSpPr>
-          <p:cNvPr id="26" name="Shape 24"/>
-          <p:cNvSpPr/>
-          <p:nvPr/>
-        </p:nvSpPr>
-        <p:spPr>
-          <a:xfrm>
-            <a:off x="1645920" y="4199382"/>
-            <a:ext cx="502920" cy="144018"/>
+            <a:endParaRPr lang="en-US" sz="600" dirty="0"/>
+          </a:p>
+        </p:txBody>
+      </p:sp>
+      <p:sp>
+        <p:nvSpPr>
+          <p:cNvPr id="40" name="Shape 38"/>
+          <p:cNvSpPr/>
+          <p:nvPr/>
+        </p:nvSpPr>
+        <p:spPr>
+          <a:xfrm>
+            <a:off x="1645920" y="4258437"/>
+            <a:ext cx="502920" cy="203835"/>
           </a:xfrm>
           <a:prstGeom prst="rect">
             <a:avLst/>
@@ -17968,14 +18430,14 @@
       </p:sp>
       <p:sp>
         <p:nvSpPr>
-          <p:cNvPr id="27" name="Text 25"/>
-          <p:cNvSpPr/>
-          <p:nvPr/>
-        </p:nvSpPr>
-        <p:spPr>
-          <a:xfrm>
-            <a:off x="1645920" y="4370832"/>
-            <a:ext cx="502920" cy="137160"/>
+          <p:cNvPr id="41" name="Text 39"/>
+          <p:cNvSpPr/>
+          <p:nvPr/>
+        </p:nvSpPr>
+        <p:spPr>
+          <a:xfrm>
+            <a:off x="1645920" y="4480560"/>
+            <a:ext cx="502920" cy="109728"/>
           </a:xfrm>
           <a:prstGeom prst="rect">
             <a:avLst/>
@@ -17991,7 +18453,7 @@
               <a:buNone/>
             </a:pPr>
             <a:r>
-              <a:rPr lang="en-US" sz="650" dirty="0">
+              <a:rPr lang="en-US" sz="600" dirty="0">
                 <a:solidFill>
                   <a:srgbClr val="5B6C77"/>
                 </a:solidFill>
@@ -17999,22 +18461,22 @@
                 <a:ea typeface="Arial" pitchFamily="34" charset="-122"/>
                 <a:cs typeface="Arial" pitchFamily="34" charset="-120"/>
               </a:rPr>
-              <a:t>Users</a:t>
-            </a:r>
-            <a:endParaRPr lang="en-US" sz="650" dirty="0"/>
-          </a:p>
-        </p:txBody>
-      </p:sp>
-      <p:sp>
-        <p:nvSpPr>
-          <p:cNvPr id="28" name="Shape 26"/>
-          <p:cNvSpPr/>
-          <p:nvPr/>
-        </p:nvSpPr>
-        <p:spPr>
-          <a:xfrm>
-            <a:off x="2606040" y="4117086"/>
-            <a:ext cx="502920" cy="226314"/>
+              <a:t>Providers</a:t>
+            </a:r>
+            <a:endParaRPr lang="en-US" sz="600" dirty="0"/>
+          </a:p>
+        </p:txBody>
+      </p:sp>
+      <p:sp>
+        <p:nvSpPr>
+          <p:cNvPr id="42" name="Shape 40"/>
+          <p:cNvSpPr/>
+          <p:nvPr/>
+        </p:nvSpPr>
+        <p:spPr>
+          <a:xfrm>
+            <a:off x="2606040" y="4336542"/>
+            <a:ext cx="502920" cy="125730"/>
           </a:xfrm>
           <a:prstGeom prst="rect">
             <a:avLst/>
@@ -18027,14 +18489,14 @@
       </p:sp>
       <p:sp>
         <p:nvSpPr>
-          <p:cNvPr id="29" name="Text 27"/>
-          <p:cNvSpPr/>
-          <p:nvPr/>
-        </p:nvSpPr>
-        <p:spPr>
-          <a:xfrm>
-            <a:off x="2606040" y="4370832"/>
-            <a:ext cx="502920" cy="137160"/>
+          <p:cNvPr id="43" name="Text 41"/>
+          <p:cNvSpPr/>
+          <p:nvPr/>
+        </p:nvSpPr>
+        <p:spPr>
+          <a:xfrm>
+            <a:off x="2606040" y="4480560"/>
+            <a:ext cx="502920" cy="109728"/>
           </a:xfrm>
           <a:prstGeom prst="rect">
             <a:avLst/>
@@ -18050,7 +18512,7 @@
               <a:buNone/>
             </a:pPr>
             <a:r>
-              <a:rPr lang="en-US" sz="650" dirty="0">
+              <a:rPr lang="en-US" sz="600" dirty="0">
                 <a:solidFill>
                   <a:srgbClr val="5B6C77"/>
                 </a:solidFill>
@@ -18058,22 +18520,22 @@
                 <a:ea typeface="Arial" pitchFamily="34" charset="-122"/>
                 <a:cs typeface="Arial" pitchFamily="34" charset="-120"/>
               </a:rPr>
-              <a:t>Providers</a:t>
-            </a:r>
-            <a:endParaRPr lang="en-US" sz="650" dirty="0"/>
-          </a:p>
-        </p:txBody>
-      </p:sp>
-      <p:sp>
-        <p:nvSpPr>
-          <p:cNvPr id="30" name="Shape 28"/>
-          <p:cNvSpPr/>
-          <p:nvPr/>
-        </p:nvSpPr>
-        <p:spPr>
-          <a:xfrm>
-            <a:off x="3566160" y="4261104"/>
-            <a:ext cx="502920" cy="82296"/>
+              <a:t>Users</a:t>
+            </a:r>
+            <a:endParaRPr lang="en-US" sz="600" dirty="0"/>
+          </a:p>
+        </p:txBody>
+      </p:sp>
+      <p:sp>
+        <p:nvSpPr>
+          <p:cNvPr id="44" name="Shape 42"/>
+          <p:cNvSpPr/>
+          <p:nvPr/>
+        </p:nvSpPr>
+        <p:spPr>
+          <a:xfrm>
+            <a:off x="3566160" y="4389120"/>
+            <a:ext cx="502920" cy="73152"/>
           </a:xfrm>
           <a:prstGeom prst="rect">
             <a:avLst/>
@@ -18086,14 +18548,14 @@
       </p:sp>
       <p:sp>
         <p:nvSpPr>
-          <p:cNvPr id="31" name="Text 29"/>
-          <p:cNvSpPr/>
-          <p:nvPr/>
-        </p:nvSpPr>
-        <p:spPr>
-          <a:xfrm>
-            <a:off x="3566160" y="4370832"/>
-            <a:ext cx="502920" cy="137160"/>
+          <p:cNvPr id="45" name="Text 43"/>
+          <p:cNvSpPr/>
+          <p:nvPr/>
+        </p:nvSpPr>
+        <p:spPr>
+          <a:xfrm>
+            <a:off x="3566160" y="4480560"/>
+            <a:ext cx="502920" cy="109728"/>
           </a:xfrm>
           <a:prstGeom prst="rect">
             <a:avLst/>
@@ -18109,7 +18571,7 @@
               <a:buNone/>
             </a:pPr>
             <a:r>
-              <a:rPr lang="en-US" sz="650" dirty="0">
+              <a:rPr lang="en-US" sz="600" dirty="0">
                 <a:solidFill>
                   <a:srgbClr val="5B6C77"/>
                 </a:solidFill>
@@ -18119,20 +18581,20 @@
               </a:rPr>
               <a:t>Accounts</a:t>
             </a:r>
-            <a:endParaRPr lang="en-US" sz="650" dirty="0"/>
-          </a:p>
-        </p:txBody>
-      </p:sp>
-      <p:sp>
-        <p:nvSpPr>
-          <p:cNvPr id="32" name="Shape 30"/>
-          <p:cNvSpPr/>
-          <p:nvPr/>
-        </p:nvSpPr>
-        <p:spPr>
-          <a:xfrm>
-            <a:off x="4526280" y="4178808"/>
-            <a:ext cx="502920" cy="164592"/>
+            <a:endParaRPr lang="en-US" sz="600" dirty="0"/>
+          </a:p>
+        </p:txBody>
+      </p:sp>
+      <p:sp>
+        <p:nvSpPr>
+          <p:cNvPr id="46" name="Shape 44"/>
+          <p:cNvSpPr/>
+          <p:nvPr/>
+        </p:nvSpPr>
+        <p:spPr>
+          <a:xfrm>
+            <a:off x="4526280" y="4358450"/>
+            <a:ext cx="502920" cy="103823"/>
           </a:xfrm>
           <a:prstGeom prst="rect">
             <a:avLst/>
@@ -18145,14 +18607,14 @@
       </p:sp>
       <p:sp>
         <p:nvSpPr>
-          <p:cNvPr id="33" name="Text 31"/>
-          <p:cNvSpPr/>
-          <p:nvPr/>
-        </p:nvSpPr>
-        <p:spPr>
-          <a:xfrm>
-            <a:off x="4526280" y="4370832"/>
-            <a:ext cx="502920" cy="137160"/>
+          <p:cNvPr id="47" name="Text 45"/>
+          <p:cNvSpPr/>
+          <p:nvPr/>
+        </p:nvSpPr>
+        <p:spPr>
+          <a:xfrm>
+            <a:off x="4526280" y="4480560"/>
+            <a:ext cx="502920" cy="109728"/>
           </a:xfrm>
           <a:prstGeom prst="rect">
             <a:avLst/>
@@ -18168,7 +18630,7 @@
               <a:buNone/>
             </a:pPr>
             <a:r>
-              <a:rPr lang="en-US" sz="650" dirty="0">
+              <a:rPr lang="en-US" sz="600" dirty="0">
                 <a:solidFill>
                   <a:srgbClr val="5B6C77"/>
                 </a:solidFill>
@@ -18178,24 +18640,24 @@
               </a:rPr>
               <a:t>Leads</a:t>
             </a:r>
-            <a:endParaRPr lang="en-US" sz="650" dirty="0"/>
-          </a:p>
-        </p:txBody>
-      </p:sp>
-      <p:sp>
-        <p:nvSpPr>
-          <p:cNvPr id="34" name="Shape 32"/>
-          <p:cNvSpPr/>
-          <p:nvPr/>
-        </p:nvSpPr>
-        <p:spPr>
-          <a:xfrm>
-            <a:off x="5760720" y="3657600"/>
-            <a:ext cx="2880360" cy="914400"/>
+            <a:endParaRPr lang="en-US" sz="600" dirty="0"/>
+          </a:p>
+        </p:txBody>
+      </p:sp>
+      <p:sp>
+        <p:nvSpPr>
+          <p:cNvPr id="48" name="Shape 46"/>
+          <p:cNvSpPr/>
+          <p:nvPr/>
+        </p:nvSpPr>
+        <p:spPr>
+          <a:xfrm>
+            <a:off x="5760720" y="3611880"/>
+            <a:ext cx="2880360" cy="960120"/>
           </a:xfrm>
           <a:prstGeom prst="roundRect">
             <a:avLst>
-              <a:gd name="adj" fmla="val 8000"/>
+              <a:gd name="adj" fmla="val 7619"/>
             </a:avLst>
           </a:prstGeom>
           <a:solidFill>
@@ -18206,14 +18668,14 @@
       </p:sp>
       <p:sp>
         <p:nvSpPr>
-          <p:cNvPr id="35" name="Text 33"/>
-          <p:cNvSpPr/>
-          <p:nvPr/>
-        </p:nvSpPr>
-        <p:spPr>
-          <a:xfrm>
-            <a:off x="5897880" y="3794760"/>
-            <a:ext cx="2606040" cy="685800"/>
+          <p:cNvPr id="49" name="Text 47"/>
+          <p:cNvSpPr/>
+          <p:nvPr/>
+        </p:nvSpPr>
+        <p:spPr>
+          <a:xfrm>
+            <a:off x="5897880" y="3749040"/>
+            <a:ext cx="2606040" cy="731520"/>
           </a:xfrm>
           <a:prstGeom prst="rect">
             <a:avLst/>
@@ -18245,13 +18707,13 @@
       </p:sp>
       <p:sp>
         <p:nvSpPr>
-          <p:cNvPr id="36" name="Text 34"/>
-          <p:cNvSpPr/>
-          <p:nvPr/>
-        </p:nvSpPr>
-        <p:spPr>
-          <a:xfrm>
-            <a:off x="502920" y="4617720"/>
+          <p:cNvPr id="50" name="Text 48"/>
+          <p:cNvSpPr/>
+          <p:nvPr/>
+        </p:nvSpPr>
+        <p:spPr>
+          <a:xfrm>
+            <a:off x="502920" y="4590288"/>
             <a:ext cx="8138160" cy="182880"/>
           </a:xfrm>
           <a:prstGeom prst="rect">
@@ -18276,7 +18738,7 @@
                 <a:ea typeface="Arial" pitchFamily="34" charset="-122"/>
                 <a:cs typeface="Arial" pitchFamily="34" charset="-120"/>
               </a:rPr>
-              <a:t>Current figures from supplied materials — August 2026</a:t>
+              <a:t>Live analytics pulled from nyumbasearch.com · August 2026</a:t>
             </a:r>
             <a:endParaRPr lang="en-US" sz="700" dirty="0"/>
           </a:p>
@@ -18284,7 +18746,7 @@
       </p:sp>
       <p:sp>
         <p:nvSpPr>
-          <p:cNvPr id="37" name="Text 35"/>
+          <p:cNvPr id="51" name="Text 49"/>
           <p:cNvSpPr/>
           <p:nvPr/>
         </p:nvSpPr>
@@ -18323,7 +18785,7 @@
       </p:sp>
       <p:sp>
         <p:nvSpPr>
-          <p:cNvPr id="38" name="Text 36"/>
+          <p:cNvPr id="52" name="Text 50"/>
           <p:cNvSpPr/>
           <p:nvPr/>
         </p:nvSpPr>
@@ -21328,7 +21790,7 @@
                 <a:ea typeface="Arial" pitchFamily="34" charset="-122"/>
                 <a:cs typeface="Arial" pitchFamily="34" charset="-120"/>
               </a:rPr>
-              <a:t>Illustrative pricing assumptions — subject to validation. Current revenue: not disclosed / early monetization stage.</a:t>
+              <a:t>Illustrative pricing assumptions — subject to validation. Full-sector activation estimate: USD 2.5M – 4.5M+ annually. Current revenue: not disclosed.</a:t>
             </a:r>
             <a:endParaRPr lang="en-US" sz="700" dirty="0"/>
           </a:p>

</xml_diff>

<commit_message>
Fix investor deck closing slide contact text overlap
The closing slide was double-rendering contact info because the full
reference JPEG already contained baked-in text. Split the layout into a
clean living-room crop on the right and a single programmatic text panel
on the left with properly spaced contact rows matching the reference.

Co-authored-by: da-homi3 <da-homi3@users.noreply.github.com>
</commit_message>
<xml_diff>
--- a/investor-deck/NyumbaSearch_Investor_Deck_August_2026.pptx
+++ b/investor-deck/NyumbaSearch_Investor_Deck_August_2026.pptx
@@ -12484,13 +12484,6 @@
 <file path=ppt/slides/slide16.xml><?xml version="1.0" encoding="utf-8"?>
 <p:sld xmlns:a="http://schemas.openxmlformats.org/drawingml/2006/main" xmlns:r="http://schemas.openxmlformats.org/officeDocument/2006/relationships" xmlns:p="http://schemas.openxmlformats.org/presentationml/2006/main">
   <p:cSld name="Slide 16">
-    <p:bg>
-      <p:bgPr>
-        <a:solidFill>
-          <a:srgbClr val="08192B"/>
-        </a:solidFill>
-      </p:bgPr>
-    </p:bg>
     <p:spTree>
       <p:nvGrpSpPr>
         <p:cNvPr id="1" name=""/>
@@ -12507,53 +12500,140 @@
       </p:grpSpPr>
       <p:sp>
         <p:nvSpPr>
-          <p:cNvPr id="2" name="Text 0"/>
-          <p:cNvSpPr/>
-          <p:nvPr/>
-        </p:nvSpPr>
-        <p:spPr>
-          <a:xfrm>
-            <a:off x="502920" y="384048"/>
-            <a:ext cx="7772400" cy="201168"/>
-          </a:xfrm>
-          <a:prstGeom prst="rect">
-            <a:avLst/>
-          </a:prstGeom>
-          <a:noFill/>
-          <a:ln/>
-        </p:spPr>
-        <p:txBody>
-          <a:bodyPr wrap="square" rtlCol="0" anchor="ctr"/>
+          <p:cNvPr id="2" name="Shape 0"/>
+          <p:cNvSpPr/>
+          <p:nvPr/>
+        </p:nvSpPr>
+        <p:spPr>
+          <a:xfrm>
+            <a:off x="0" y="0"/>
+            <a:ext cx="9144000" cy="5143500"/>
+          </a:xfrm>
+          <a:prstGeom prst="rect">
+            <a:avLst/>
+          </a:prstGeom>
+          <a:solidFill>
+            <a:srgbClr val="3D1F0F"/>
+          </a:solidFill>
+          <a:ln/>
+        </p:spPr>
+      </p:sp>
+      <p:pic>
+        <p:nvPicPr>
+          <p:cNvPr id="3" name="Image 0" descr="/workspace/investor-deck/assets/closing-living-room.jpg">    </p:cNvPr>
+          <p:cNvPicPr>
+            <a:picLocks noChangeAspect="1"/>
+          </p:cNvPicPr>
+          <p:nvPr/>
+        </p:nvPicPr>
+        <p:blipFill>
+          <a:blip r:embed="rId1"/>
+          <a:srcRect l="0" r="0" t="0" b="0"/>
+          <a:stretch/>
+        </p:blipFill>
+        <p:spPr>
+          <a:xfrm>
+            <a:off x="4434840" y="0"/>
+            <a:ext cx="4709160" cy="5143500"/>
+          </a:xfrm>
+          <a:prstGeom prst="rect">
+            <a:avLst/>
+          </a:prstGeom>
+        </p:spPr>
+      </p:pic>
+      <p:sp>
+        <p:nvSpPr>
+          <p:cNvPr id="4" name="Shape 1"/>
+          <p:cNvSpPr/>
+          <p:nvPr/>
+        </p:nvSpPr>
+        <p:spPr>
+          <a:xfrm>
+            <a:off x="0" y="0"/>
+            <a:ext cx="5669280" cy="5143500"/>
+          </a:xfrm>
+          <a:prstGeom prst="rect">
+            <a:avLst/>
+          </a:prstGeom>
+          <a:solidFill>
+            <a:srgbClr val="3D1F0F">
+              <a:alpha val="95000"/>
+            </a:srgbClr>
+          </a:solidFill>
+          <a:ln/>
+        </p:spPr>
+      </p:sp>
+      <p:sp>
+        <p:nvSpPr>
+          <p:cNvPr id="5" name="Shape 2"/>
+          <p:cNvSpPr/>
+          <p:nvPr/>
+        </p:nvSpPr>
+        <p:spPr>
+          <a:xfrm>
+            <a:off x="4206240" y="0"/>
+            <a:ext cx="1463040" cy="5143500"/>
+          </a:xfrm>
+          <a:prstGeom prst="rect">
+            <a:avLst/>
+          </a:prstGeom>
+          <a:solidFill>
+            <a:srgbClr val="3D1F0F">
+              <a:alpha val="50000"/>
+            </a:srgbClr>
+          </a:solidFill>
+          <a:ln/>
+        </p:spPr>
+      </p:sp>
+      <p:sp>
+        <p:nvSpPr>
+          <p:cNvPr id="6" name="Text 3"/>
+          <p:cNvSpPr/>
+          <p:nvPr/>
+        </p:nvSpPr>
+        <p:spPr>
+          <a:xfrm>
+            <a:off x="594360" y="960120"/>
+            <a:ext cx="4754880" cy="640080"/>
+          </a:xfrm>
+          <a:prstGeom prst="rect">
+            <a:avLst/>
+          </a:prstGeom>
+          <a:noFill/>
+          <a:ln/>
+        </p:spPr>
+        <p:txBody>
+          <a:bodyPr wrap="square" rtlCol="0" anchor="t"/>
           <a:lstStyle/>
           <a:p>
             <a:pPr indent="0" marL="0">
               <a:buNone/>
             </a:pPr>
             <a:r>
-              <a:rPr lang="en-US" sz="900" b="1" spc="120" kern="0" dirty="0">
-                <a:solidFill>
-                  <a:srgbClr val="19995C"/>
-                </a:solidFill>
-                <a:latin typeface="Arial" pitchFamily="34" charset="0"/>
-                <a:ea typeface="Arial" pitchFamily="34" charset="-122"/>
-                <a:cs typeface="Arial" pitchFamily="34" charset="-120"/>
-              </a:rPr>
-              <a:t>INVESTMENT OPPORTUNITY</a:t>
-            </a:r>
-            <a:endParaRPr lang="en-US" sz="900" dirty="0"/>
-          </a:p>
-        </p:txBody>
-      </p:sp>
-      <p:sp>
-        <p:nvSpPr>
-          <p:cNvPr id="3" name="Text 1"/>
-          <p:cNvSpPr/>
-          <p:nvPr/>
-        </p:nvSpPr>
-        <p:spPr>
-          <a:xfrm>
-            <a:off x="502920" y="621792"/>
-            <a:ext cx="8138160" cy="502920"/>
+              <a:rPr lang="en-US" sz="3600" b="1" dirty="0">
+                <a:solidFill>
+                  <a:srgbClr val="FAFCFA"/>
+                </a:solidFill>
+                <a:latin typeface="Arial" pitchFamily="34" charset="0"/>
+                <a:ea typeface="Arial" pitchFamily="34" charset="-122"/>
+                <a:cs typeface="Arial" pitchFamily="34" charset="-120"/>
+              </a:rPr>
+              <a:t>THANK YOU!</a:t>
+            </a:r>
+            <a:endParaRPr lang="en-US" sz="3600" dirty="0"/>
+          </a:p>
+        </p:txBody>
+      </p:sp>
+      <p:sp>
+        <p:nvSpPr>
+          <p:cNvPr id="7" name="Text 4"/>
+          <p:cNvSpPr/>
+          <p:nvPr/>
+        </p:nvSpPr>
+        <p:spPr>
+          <a:xfrm>
+            <a:off x="594360" y="1664208"/>
+            <a:ext cx="4572000" cy="411480"/>
           </a:xfrm>
           <a:prstGeom prst="rect">
             <a:avLst/>
@@ -12569,120 +12649,59 @@
               <a:buNone/>
             </a:pPr>
             <a:r>
-              <a:rPr lang="en-US" sz="3000" b="1" dirty="0">
-                <a:solidFill>
-                  <a:srgbClr val="FAFCFA"/>
-                </a:solidFill>
-                <a:latin typeface="Arial" pitchFamily="34" charset="0"/>
-                <a:ea typeface="Arial" pitchFamily="34" charset="-122"/>
-                <a:cs typeface="Arial" pitchFamily="34" charset="-120"/>
-              </a:rPr>
-              <a:t>The next home infrastructure layer.</a:t>
-            </a:r>
-            <a:endParaRPr lang="en-US" sz="3000" dirty="0"/>
-          </a:p>
-        </p:txBody>
-      </p:sp>
-      <p:sp>
-        <p:nvSpPr>
-          <p:cNvPr id="4" name="Text 2"/>
-          <p:cNvSpPr/>
-          <p:nvPr/>
-        </p:nvSpPr>
-        <p:spPr>
-          <a:xfrm>
-            <a:off x="502920" y="1115568"/>
-            <a:ext cx="8138160" cy="256032"/>
-          </a:xfrm>
-          <a:prstGeom prst="rect">
-            <a:avLst/>
-          </a:prstGeom>
-          <a:noFill/>
-          <a:ln/>
-        </p:spPr>
-        <p:txBody>
-          <a:bodyPr wrap="square" rtlCol="0" anchor="ctr"/>
-          <a:lstStyle/>
+              <a:rPr lang="en-US" sz="1300" dirty="0">
+                <a:solidFill>
+                  <a:srgbClr val="E8DDD4"/>
+                </a:solidFill>
+                <a:latin typeface="Arial" pitchFamily="34" charset="0"/>
+                <a:ea typeface="Arial" pitchFamily="34" charset="-122"/>
+                <a:cs typeface="Arial" pitchFamily="34" charset="-120"/>
+              </a:rPr>
+              <a:t>Building the housing infrastructure</a:t>
+            </a:r>
+            <a:endParaRPr lang="en-US" sz="1300" dirty="0"/>
+          </a:p>
           <a:p>
             <a:pPr indent="0" marL="0">
               <a:buNone/>
             </a:pPr>
             <a:r>
-              <a:rPr lang="en-US" sz="1200" dirty="0">
-                <a:solidFill>
-                  <a:srgbClr val="F4F7F5"/>
-                </a:solidFill>
-                <a:latin typeface="Arial" pitchFamily="34" charset="0"/>
-                <a:ea typeface="Arial" pitchFamily="34" charset="-122"/>
-                <a:cs typeface="Arial" pitchFamily="34" charset="-120"/>
-              </a:rPr>
-              <a:t>NyumbaSearch is building more than a property marketplace.</a:t>
-            </a:r>
-            <a:endParaRPr lang="en-US" sz="1200" dirty="0"/>
-          </a:p>
-        </p:txBody>
-      </p:sp>
-      <p:sp>
-        <p:nvSpPr>
-          <p:cNvPr id="5" name="Text 3"/>
-          <p:cNvSpPr/>
-          <p:nvPr/>
-        </p:nvSpPr>
-        <p:spPr>
-          <a:xfrm>
-            <a:off x="502920" y="1389888"/>
-            <a:ext cx="8138160" cy="347472"/>
-          </a:xfrm>
-          <a:prstGeom prst="rect">
-            <a:avLst/>
-          </a:prstGeom>
-          <a:noFill/>
-          <a:ln/>
-        </p:spPr>
-        <p:txBody>
-          <a:bodyPr wrap="square" rtlCol="0" anchor="ctr"/>
-          <a:lstStyle/>
-          <a:p>
-            <a:pPr indent="0" marL="0">
-              <a:buNone/>
-            </a:pPr>
-            <a:r>
-              <a:rPr lang="en-US" sz="1100" dirty="0">
-                <a:solidFill>
-                  <a:srgbClr val="5B6C77"/>
-                </a:solidFill>
-                <a:latin typeface="Arial" pitchFamily="34" charset="0"/>
-                <a:ea typeface="Arial" pitchFamily="34" charset="-122"/>
-                <a:cs typeface="Arial" pitchFamily="34" charset="-120"/>
-              </a:rPr>
-              <a:t>We are building a trusted ecosystem connecting people, properties, payments and home services.</a:t>
-            </a:r>
-            <a:endParaRPr lang="en-US" sz="1100" dirty="0"/>
-          </a:p>
-        </p:txBody>
-      </p:sp>
-      <p:sp>
-        <p:nvSpPr>
-          <p:cNvPr id="6" name="Shape 4"/>
-          <p:cNvSpPr/>
-          <p:nvPr/>
-        </p:nvSpPr>
-        <p:spPr>
-          <a:xfrm>
-            <a:off x="502920" y="2011680"/>
-            <a:ext cx="1965960" cy="868680"/>
-          </a:xfrm>
-          <a:prstGeom prst="roundRect">
-            <a:avLst>
-              <a:gd name="adj" fmla="val 8421"/>
-            </a:avLst>
+              <a:rPr lang="en-US" sz="1300" dirty="0">
+                <a:solidFill>
+                  <a:srgbClr val="E8DDD4"/>
+                </a:solidFill>
+                <a:latin typeface="Arial" pitchFamily="34" charset="0"/>
+                <a:ea typeface="Arial" pitchFamily="34" charset="-122"/>
+                <a:cs typeface="Arial" pitchFamily="34" charset="-120"/>
+              </a:rPr>
+              <a:t>Africa deserves.</a:t>
+            </a:r>
+            <a:endParaRPr lang="en-US" sz="1300" dirty="0"/>
+          </a:p>
+        </p:txBody>
+      </p:sp>
+      <p:sp>
+        <p:nvSpPr>
+          <p:cNvPr id="8" name="Shape 5"/>
+          <p:cNvSpPr/>
+          <p:nvPr/>
+        </p:nvSpPr>
+        <p:spPr>
+          <a:xfrm>
+            <a:off x="594360" y="2395728"/>
+            <a:ext cx="329184" cy="329184"/>
+          </a:xfrm>
+          <a:prstGeom prst="ellipse">
+            <a:avLst/>
           </a:prstGeom>
           <a:solidFill>
-            <a:srgbClr val="0F2A44"/>
+            <a:srgbClr val="3D1F0F">
+              <a:alpha val="65000"/>
+            </a:srgbClr>
           </a:solidFill>
-          <a:ln w="6350">
+          <a:ln w="15240">
             <a:solidFill>
-              <a:srgbClr val="3AB570"/>
+              <a:srgbClr val="FFFFFF"/>
             </a:solidFill>
             <a:prstDash val="solid"/>
           </a:ln>
@@ -12690,14 +12709,14 @@
       </p:sp>
       <p:sp>
         <p:nvSpPr>
-          <p:cNvPr id="7" name="Text 5"/>
-          <p:cNvSpPr/>
-          <p:nvPr/>
-        </p:nvSpPr>
-        <p:spPr>
-          <a:xfrm>
-            <a:off x="502920" y="2121408"/>
-            <a:ext cx="1965960" cy="256032"/>
+          <p:cNvPr id="9" name="Text 6"/>
+          <p:cNvSpPr/>
+          <p:nvPr/>
+        </p:nvSpPr>
+        <p:spPr>
+          <a:xfrm>
+            <a:off x="594360" y="2423160"/>
+            <a:ext cx="329184" cy="274320"/>
           </a:xfrm>
           <a:prstGeom prst="rect">
             <a:avLst/>
@@ -12713,81 +12732,81 @@
               <a:buNone/>
             </a:pPr>
             <a:r>
-              <a:rPr lang="en-US" sz="1000" b="1" dirty="0">
-                <a:solidFill>
-                  <a:srgbClr val="91D64D"/>
-                </a:solidFill>
-                <a:latin typeface="Arial" pitchFamily="34" charset="0"/>
-                <a:ea typeface="Arial" pitchFamily="34" charset="-122"/>
-                <a:cs typeface="Arial" pitchFamily="34" charset="-120"/>
-              </a:rPr>
-              <a:t>DISCOVER</a:t>
-            </a:r>
-            <a:endParaRPr lang="en-US" sz="1000" dirty="0"/>
-          </a:p>
-        </p:txBody>
-      </p:sp>
-      <p:sp>
-        <p:nvSpPr>
-          <p:cNvPr id="8" name="Text 6"/>
-          <p:cNvSpPr/>
-          <p:nvPr/>
-        </p:nvSpPr>
-        <p:spPr>
-          <a:xfrm>
-            <a:off x="502920" y="2395728"/>
-            <a:ext cx="1965960" cy="320040"/>
-          </a:xfrm>
-          <a:prstGeom prst="rect">
-            <a:avLst/>
-          </a:prstGeom>
-          <a:noFill/>
-          <a:ln/>
-        </p:spPr>
-        <p:txBody>
-          <a:bodyPr wrap="square" rtlCol="0" anchor="ctr"/>
-          <a:lstStyle/>
-          <a:p>
-            <a:pPr algn="ctr" indent="0" marL="0">
-              <a:buNone/>
-            </a:pPr>
-            <a:r>
-              <a:rPr lang="en-US" sz="850" dirty="0">
-                <a:solidFill>
-                  <a:srgbClr val="F4F7F5"/>
-                </a:solidFill>
-                <a:latin typeface="Arial" pitchFamily="34" charset="0"/>
-                <a:ea typeface="Arial" pitchFamily="34" charset="-122"/>
-                <a:cs typeface="Arial" pitchFamily="34" charset="-120"/>
-              </a:rPr>
-              <a:t>Find the right home.</a:t>
-            </a:r>
-            <a:endParaRPr lang="en-US" sz="850" dirty="0"/>
-          </a:p>
-        </p:txBody>
-      </p:sp>
-      <p:sp>
-        <p:nvSpPr>
-          <p:cNvPr id="9" name="Shape 7"/>
-          <p:cNvSpPr/>
-          <p:nvPr/>
-        </p:nvSpPr>
-        <p:spPr>
-          <a:xfrm>
-            <a:off x="2651760" y="2011680"/>
-            <a:ext cx="1965960" cy="868680"/>
-          </a:xfrm>
-          <a:prstGeom prst="roundRect">
-            <a:avLst>
-              <a:gd name="adj" fmla="val 8421"/>
-            </a:avLst>
+              <a:rPr lang="en-US" sz="650" b="1" dirty="0">
+                <a:solidFill>
+                  <a:srgbClr val="FAFCFA"/>
+                </a:solidFill>
+                <a:latin typeface="Arial" pitchFamily="34" charset="0"/>
+                <a:ea typeface="Arial" pitchFamily="34" charset="-122"/>
+                <a:cs typeface="Arial" pitchFamily="34" charset="-120"/>
+              </a:rPr>
+              <a:t>www</a:t>
+            </a:r>
+            <a:endParaRPr lang="en-US" sz="650" dirty="0"/>
+          </a:p>
+        </p:txBody>
+      </p:sp>
+      <p:sp>
+        <p:nvSpPr>
+          <p:cNvPr id="10" name="Text 7"/>
+          <p:cNvSpPr/>
+          <p:nvPr/>
+        </p:nvSpPr>
+        <p:spPr>
+          <a:xfrm>
+            <a:off x="1051560" y="2423160"/>
+            <a:ext cx="4114800" cy="292608"/>
+          </a:xfrm>
+          <a:prstGeom prst="rect">
+            <a:avLst/>
+          </a:prstGeom>
+          <a:noFill/>
+          <a:ln/>
+        </p:spPr>
+        <p:txBody>
+          <a:bodyPr wrap="square" rtlCol="0" anchor="ctr"/>
+          <a:lstStyle/>
+          <a:p>
+            <a:pPr indent="0" marL="0">
+              <a:buNone/>
+            </a:pPr>
+            <a:r>
+              <a:rPr lang="en-US" sz="1200" dirty="0">
+                <a:solidFill>
+                  <a:srgbClr val="FAFCFA"/>
+                </a:solidFill>
+                <a:latin typeface="Arial" pitchFamily="34" charset="0"/>
+                <a:ea typeface="Arial" pitchFamily="34" charset="-122"/>
+                <a:cs typeface="Arial" pitchFamily="34" charset="-120"/>
+              </a:rPr>
+              <a:t>nyumbasearch.com</a:t>
+            </a:r>
+            <a:endParaRPr lang="en-US" sz="1200" dirty="0"/>
+          </a:p>
+        </p:txBody>
+      </p:sp>
+      <p:sp>
+        <p:nvSpPr>
+          <p:cNvPr id="11" name="Shape 8"/>
+          <p:cNvSpPr/>
+          <p:nvPr/>
+        </p:nvSpPr>
+        <p:spPr>
+          <a:xfrm>
+            <a:off x="594360" y="2889504"/>
+            <a:ext cx="329184" cy="329184"/>
+          </a:xfrm>
+          <a:prstGeom prst="ellipse">
+            <a:avLst/>
           </a:prstGeom>
           <a:solidFill>
-            <a:srgbClr val="0F2A44"/>
+            <a:srgbClr val="3D1F0F">
+              <a:alpha val="65000"/>
+            </a:srgbClr>
           </a:solidFill>
-          <a:ln w="6350">
+          <a:ln w="15240">
             <a:solidFill>
-              <a:srgbClr val="3AB570"/>
+              <a:srgbClr val="FFFFFF"/>
             </a:solidFill>
             <a:prstDash val="solid"/>
           </a:ln>
@@ -12795,14 +12814,14 @@
       </p:sp>
       <p:sp>
         <p:nvSpPr>
-          <p:cNvPr id="10" name="Text 8"/>
-          <p:cNvSpPr/>
-          <p:nvPr/>
-        </p:nvSpPr>
-        <p:spPr>
-          <a:xfrm>
-            <a:off x="2651760" y="2121408"/>
-            <a:ext cx="1965960" cy="256032"/>
+          <p:cNvPr id="12" name="Text 9"/>
+          <p:cNvSpPr/>
+          <p:nvPr/>
+        </p:nvSpPr>
+        <p:spPr>
+          <a:xfrm>
+            <a:off x="594360" y="2916936"/>
+            <a:ext cx="329184" cy="274320"/>
           </a:xfrm>
           <a:prstGeom prst="rect">
             <a:avLst/>
@@ -12818,81 +12837,81 @@
               <a:buNone/>
             </a:pPr>
             <a:r>
-              <a:rPr lang="en-US" sz="1000" b="1" dirty="0">
-                <a:solidFill>
-                  <a:srgbClr val="91D64D"/>
-                </a:solidFill>
-                <a:latin typeface="Arial" pitchFamily="34" charset="0"/>
-                <a:ea typeface="Arial" pitchFamily="34" charset="-122"/>
-                <a:cs typeface="Arial" pitchFamily="34" charset="-120"/>
-              </a:rPr>
-              <a:t>VERIFY</a:t>
-            </a:r>
-            <a:endParaRPr lang="en-US" sz="1000" dirty="0"/>
-          </a:p>
-        </p:txBody>
-      </p:sp>
-      <p:sp>
-        <p:nvSpPr>
-          <p:cNvPr id="11" name="Text 9"/>
-          <p:cNvSpPr/>
-          <p:nvPr/>
-        </p:nvSpPr>
-        <p:spPr>
-          <a:xfrm>
-            <a:off x="2651760" y="2395728"/>
-            <a:ext cx="1965960" cy="320040"/>
-          </a:xfrm>
-          <a:prstGeom prst="rect">
-            <a:avLst/>
-          </a:prstGeom>
-          <a:noFill/>
-          <a:ln/>
-        </p:spPr>
-        <p:txBody>
-          <a:bodyPr wrap="square" rtlCol="0" anchor="ctr"/>
-          <a:lstStyle/>
-          <a:p>
-            <a:pPr algn="ctr" indent="0" marL="0">
-              <a:buNone/>
-            </a:pPr>
-            <a:r>
-              <a:rPr lang="en-US" sz="850" dirty="0">
-                <a:solidFill>
-                  <a:srgbClr val="F4F7F5"/>
-                </a:solidFill>
-                <a:latin typeface="Arial" pitchFamily="34" charset="0"/>
-                <a:ea typeface="Arial" pitchFamily="34" charset="-122"/>
-                <a:cs typeface="Arial" pitchFamily="34" charset="-120"/>
-              </a:rPr>
-              <a:t>Move with confidence.</a:t>
-            </a:r>
-            <a:endParaRPr lang="en-US" sz="850" dirty="0"/>
-          </a:p>
-        </p:txBody>
-      </p:sp>
-      <p:sp>
-        <p:nvSpPr>
-          <p:cNvPr id="12" name="Shape 10"/>
-          <p:cNvSpPr/>
-          <p:nvPr/>
-        </p:nvSpPr>
-        <p:spPr>
-          <a:xfrm>
-            <a:off x="4800600" y="2011680"/>
-            <a:ext cx="1965960" cy="868680"/>
-          </a:xfrm>
-          <a:prstGeom prst="roundRect">
-            <a:avLst>
-              <a:gd name="adj" fmla="val 8421"/>
-            </a:avLst>
+              <a:rPr lang="en-US" sz="1100" dirty="0">
+                <a:solidFill>
+                  <a:srgbClr val="FAFCFA"/>
+                </a:solidFill>
+                <a:latin typeface="Arial" pitchFamily="34" charset="0"/>
+                <a:ea typeface="Arial" pitchFamily="34" charset="-122"/>
+                <a:cs typeface="Arial" pitchFamily="34" charset="-120"/>
+              </a:rPr>
+              <a:t>@</a:t>
+            </a:r>
+            <a:endParaRPr lang="en-US" sz="1100" dirty="0"/>
+          </a:p>
+        </p:txBody>
+      </p:sp>
+      <p:sp>
+        <p:nvSpPr>
+          <p:cNvPr id="13" name="Text 10"/>
+          <p:cNvSpPr/>
+          <p:nvPr/>
+        </p:nvSpPr>
+        <p:spPr>
+          <a:xfrm>
+            <a:off x="1051560" y="2916936"/>
+            <a:ext cx="4114800" cy="292608"/>
+          </a:xfrm>
+          <a:prstGeom prst="rect">
+            <a:avLst/>
+          </a:prstGeom>
+          <a:noFill/>
+          <a:ln/>
+        </p:spPr>
+        <p:txBody>
+          <a:bodyPr wrap="square" rtlCol="0" anchor="ctr"/>
+          <a:lstStyle/>
+          <a:p>
+            <a:pPr indent="0" marL="0">
+              <a:buNone/>
+            </a:pPr>
+            <a:r>
+              <a:rPr lang="en-US" sz="1200" dirty="0">
+                <a:solidFill>
+                  <a:srgbClr val="FAFCFA"/>
+                </a:solidFill>
+                <a:latin typeface="Arial" pitchFamily="34" charset="0"/>
+                <a:ea typeface="Arial" pitchFamily="34" charset="-122"/>
+                <a:cs typeface="Arial" pitchFamily="34" charset="-120"/>
+              </a:rPr>
+              <a:t>nyumbasearch101@gmail.com</a:t>
+            </a:r>
+            <a:endParaRPr lang="en-US" sz="1200" dirty="0"/>
+          </a:p>
+        </p:txBody>
+      </p:sp>
+      <p:sp>
+        <p:nvSpPr>
+          <p:cNvPr id="14" name="Shape 11"/>
+          <p:cNvSpPr/>
+          <p:nvPr/>
+        </p:nvSpPr>
+        <p:spPr>
+          <a:xfrm>
+            <a:off x="594360" y="3383280"/>
+            <a:ext cx="329184" cy="329184"/>
+          </a:xfrm>
+          <a:prstGeom prst="ellipse">
+            <a:avLst/>
           </a:prstGeom>
           <a:solidFill>
-            <a:srgbClr val="0F2A44"/>
+            <a:srgbClr val="3D1F0F">
+              <a:alpha val="65000"/>
+            </a:srgbClr>
           </a:solidFill>
-          <a:ln w="6350">
+          <a:ln w="15240">
             <a:solidFill>
-              <a:srgbClr val="3AB570"/>
+              <a:srgbClr val="FFFFFF"/>
             </a:solidFill>
             <a:prstDash val="solid"/>
           </a:ln>
@@ -12900,14 +12919,14 @@
       </p:sp>
       <p:sp>
         <p:nvSpPr>
-          <p:cNvPr id="13" name="Text 11"/>
-          <p:cNvSpPr/>
-          <p:nvPr/>
-        </p:nvSpPr>
-        <p:spPr>
-          <a:xfrm>
-            <a:off x="4800600" y="2121408"/>
-            <a:ext cx="1965960" cy="256032"/>
+          <p:cNvPr id="15" name="Text 12"/>
+          <p:cNvSpPr/>
+          <p:nvPr/>
+        </p:nvSpPr>
+        <p:spPr>
+          <a:xfrm>
+            <a:off x="594360" y="3410712"/>
+            <a:ext cx="329184" cy="274320"/>
           </a:xfrm>
           <a:prstGeom prst="rect">
             <a:avLst/>
@@ -12923,81 +12942,81 @@
               <a:buNone/>
             </a:pPr>
             <a:r>
-              <a:rPr lang="en-US" sz="1000" b="1" dirty="0">
-                <a:solidFill>
-                  <a:srgbClr val="91D64D"/>
-                </a:solidFill>
-                <a:latin typeface="Arial" pitchFamily="34" charset="0"/>
-                <a:ea typeface="Arial" pitchFamily="34" charset="-122"/>
-                <a:cs typeface="Arial" pitchFamily="34" charset="-120"/>
-              </a:rPr>
-              <a:t>MANAGE</a:t>
-            </a:r>
-            <a:endParaRPr lang="en-US" sz="1000" dirty="0"/>
-          </a:p>
-        </p:txBody>
-      </p:sp>
-      <p:sp>
-        <p:nvSpPr>
-          <p:cNvPr id="14" name="Text 12"/>
-          <p:cNvSpPr/>
-          <p:nvPr/>
-        </p:nvSpPr>
-        <p:spPr>
-          <a:xfrm>
-            <a:off x="4800600" y="2395728"/>
-            <a:ext cx="1965960" cy="320040"/>
-          </a:xfrm>
-          <a:prstGeom prst="rect">
-            <a:avLst/>
-          </a:prstGeom>
-          <a:noFill/>
-          <a:ln/>
-        </p:spPr>
-        <p:txBody>
-          <a:bodyPr wrap="square" rtlCol="0" anchor="ctr"/>
-          <a:lstStyle/>
-          <a:p>
-            <a:pPr algn="ctr" indent="0" marL="0">
-              <a:buNone/>
-            </a:pPr>
-            <a:r>
-              <a:rPr lang="en-US" sz="850" dirty="0">
-                <a:solidFill>
-                  <a:srgbClr val="F4F7F5"/>
-                </a:solidFill>
-                <a:latin typeface="Arial" pitchFamily="34" charset="0"/>
-                <a:ea typeface="Arial" pitchFamily="34" charset="-122"/>
-                <a:cs typeface="Arial" pitchFamily="34" charset="-120"/>
-              </a:rPr>
-              <a:t>Operate the tenancy.</a:t>
-            </a:r>
-            <a:endParaRPr lang="en-US" sz="850" dirty="0"/>
-          </a:p>
-        </p:txBody>
-      </p:sp>
-      <p:sp>
-        <p:nvSpPr>
-          <p:cNvPr id="15" name="Shape 13"/>
-          <p:cNvSpPr/>
-          <p:nvPr/>
-        </p:nvSpPr>
-        <p:spPr>
-          <a:xfrm>
-            <a:off x="6949440" y="2011680"/>
-            <a:ext cx="1965960" cy="868680"/>
-          </a:xfrm>
-          <a:prstGeom prst="roundRect">
-            <a:avLst>
-              <a:gd name="adj" fmla="val 8421"/>
-            </a:avLst>
+              <a:rPr lang="en-US" sz="1100" dirty="0">
+                <a:solidFill>
+                  <a:srgbClr val="FAFCFA"/>
+                </a:solidFill>
+                <a:latin typeface="Arial" pitchFamily="34" charset="0"/>
+                <a:ea typeface="Arial" pitchFamily="34" charset="-122"/>
+                <a:cs typeface="Arial" pitchFamily="34" charset="-120"/>
+              </a:rPr>
+              <a:t>+</a:t>
+            </a:r>
+            <a:endParaRPr lang="en-US" sz="1100" dirty="0"/>
+          </a:p>
+        </p:txBody>
+      </p:sp>
+      <p:sp>
+        <p:nvSpPr>
+          <p:cNvPr id="16" name="Text 13"/>
+          <p:cNvSpPr/>
+          <p:nvPr/>
+        </p:nvSpPr>
+        <p:spPr>
+          <a:xfrm>
+            <a:off x="1051560" y="3410712"/>
+            <a:ext cx="4114800" cy="292608"/>
+          </a:xfrm>
+          <a:prstGeom prst="rect">
+            <a:avLst/>
+          </a:prstGeom>
+          <a:noFill/>
+          <a:ln/>
+        </p:spPr>
+        <p:txBody>
+          <a:bodyPr wrap="square" rtlCol="0" anchor="ctr"/>
+          <a:lstStyle/>
+          <a:p>
+            <a:pPr indent="0" marL="0">
+              <a:buNone/>
+            </a:pPr>
+            <a:r>
+              <a:rPr lang="en-US" sz="1200" dirty="0">
+                <a:solidFill>
+                  <a:srgbClr val="FAFCFA"/>
+                </a:solidFill>
+                <a:latin typeface="Arial" pitchFamily="34" charset="0"/>
+                <a:ea typeface="Arial" pitchFamily="34" charset="-122"/>
+                <a:cs typeface="Arial" pitchFamily="34" charset="-120"/>
+              </a:rPr>
+              <a:t>+254714725598</a:t>
+            </a:r>
+            <a:endParaRPr lang="en-US" sz="1200" dirty="0"/>
+          </a:p>
+        </p:txBody>
+      </p:sp>
+      <p:sp>
+        <p:nvSpPr>
+          <p:cNvPr id="17" name="Shape 14"/>
+          <p:cNvSpPr/>
+          <p:nvPr/>
+        </p:nvSpPr>
+        <p:spPr>
+          <a:xfrm>
+            <a:off x="594360" y="3877056"/>
+            <a:ext cx="329184" cy="329184"/>
+          </a:xfrm>
+          <a:prstGeom prst="ellipse">
+            <a:avLst/>
           </a:prstGeom>
           <a:solidFill>
-            <a:srgbClr val="0F2A44"/>
+            <a:srgbClr val="3D1F0F">
+              <a:alpha val="65000"/>
+            </a:srgbClr>
           </a:solidFill>
-          <a:ln w="6350">
+          <a:ln w="15240">
             <a:solidFill>
-              <a:srgbClr val="3AB570"/>
+              <a:srgbClr val="FFFFFF"/>
             </a:solidFill>
             <a:prstDash val="solid"/>
           </a:ln>
@@ -13005,14 +13024,14 @@
       </p:sp>
       <p:sp>
         <p:nvSpPr>
-          <p:cNvPr id="16" name="Text 14"/>
-          <p:cNvSpPr/>
-          <p:nvPr/>
-        </p:nvSpPr>
-        <p:spPr>
-          <a:xfrm>
-            <a:off x="6949440" y="2121408"/>
-            <a:ext cx="1965960" cy="256032"/>
+          <p:cNvPr id="18" name="Text 15"/>
+          <p:cNvSpPr/>
+          <p:nvPr/>
+        </p:nvSpPr>
+        <p:spPr>
+          <a:xfrm>
+            <a:off x="594360" y="3904488"/>
+            <a:ext cx="329184" cy="274320"/>
           </a:xfrm>
           <a:prstGeom prst="rect">
             <a:avLst/>
@@ -13028,107 +13047,7 @@
               <a:buNone/>
             </a:pPr>
             <a:r>
-              <a:rPr lang="en-US" sz="1000" b="1" dirty="0">
-                <a:solidFill>
-                  <a:srgbClr val="91D64D"/>
-                </a:solidFill>
-                <a:latin typeface="Arial" pitchFamily="34" charset="0"/>
-                <a:ea typeface="Arial" pitchFamily="34" charset="-122"/>
-                <a:cs typeface="Arial" pitchFamily="34" charset="-120"/>
-              </a:rPr>
-              <a:t>SERVE</a:t>
-            </a:r>
-            <a:endParaRPr lang="en-US" sz="1000" dirty="0"/>
-          </a:p>
-        </p:txBody>
-      </p:sp>
-      <p:sp>
-        <p:nvSpPr>
-          <p:cNvPr id="17" name="Text 15"/>
-          <p:cNvSpPr/>
-          <p:nvPr/>
-        </p:nvSpPr>
-        <p:spPr>
-          <a:xfrm>
-            <a:off x="6949440" y="2395728"/>
-            <a:ext cx="1965960" cy="320040"/>
-          </a:xfrm>
-          <a:prstGeom prst="rect">
-            <a:avLst/>
-          </a:prstGeom>
-          <a:noFill/>
-          <a:ln/>
-        </p:spPr>
-        <p:txBody>
-          <a:bodyPr wrap="square" rtlCol="0" anchor="ctr"/>
-          <a:lstStyle/>
-          <a:p>
-            <a:pPr algn="ctr" indent="0" marL="0">
-              <a:buNone/>
-            </a:pPr>
-            <a:r>
-              <a:rPr lang="en-US" sz="850" dirty="0">
-                <a:solidFill>
-                  <a:srgbClr val="F4F7F5"/>
-                </a:solidFill>
-                <a:latin typeface="Arial" pitchFamily="34" charset="0"/>
-                <a:ea typeface="Arial" pitchFamily="34" charset="-122"/>
-                <a:cs typeface="Arial" pitchFamily="34" charset="-120"/>
-              </a:rPr>
-              <a:t>Access trusted services.</a:t>
-            </a:r>
-            <a:endParaRPr lang="en-US" sz="850" dirty="0"/>
-          </a:p>
-        </p:txBody>
-      </p:sp>
-      <p:sp>
-        <p:nvSpPr>
-          <p:cNvPr id="18" name="Shape 16"/>
-          <p:cNvSpPr/>
-          <p:nvPr/>
-        </p:nvSpPr>
-        <p:spPr>
-          <a:xfrm>
-            <a:off x="502920" y="3108960"/>
-            <a:ext cx="8138160" cy="411480"/>
-          </a:xfrm>
-          <a:prstGeom prst="roundRect">
-            <a:avLst>
-              <a:gd name="adj" fmla="val 17778"/>
-            </a:avLst>
-          </a:prstGeom>
-          <a:solidFill>
-            <a:srgbClr val="19995C"/>
-          </a:solidFill>
-          <a:ln/>
-        </p:spPr>
-      </p:sp>
-      <p:sp>
-        <p:nvSpPr>
-          <p:cNvPr id="19" name="Text 17"/>
-          <p:cNvSpPr/>
-          <p:nvPr/>
-        </p:nvSpPr>
-        <p:spPr>
-          <a:xfrm>
-            <a:off x="502920" y="3182112"/>
-            <a:ext cx="8138160" cy="292608"/>
-          </a:xfrm>
-          <a:prstGeom prst="rect">
-            <a:avLst/>
-          </a:prstGeom>
-          <a:noFill/>
-          <a:ln/>
-        </p:spPr>
-        <p:txBody>
-          <a:bodyPr wrap="square" rtlCol="0" anchor="ctr"/>
-          <a:lstStyle/>
-          <a:p>
-            <a:pPr algn="ctr" indent="0" marL="0">
-              <a:buNone/>
-            </a:pPr>
-            <a:r>
-              <a:rPr lang="en-US" sz="1100" b="1" dirty="0">
+              <a:rPr lang="en-US" sz="1100" dirty="0">
                 <a:solidFill>
                   <a:srgbClr val="FAFCFA"/>
                 </a:solidFill>
@@ -13136,7 +13055,7 @@
                 <a:ea typeface="Arial" pitchFamily="34" charset="-122"/>
                 <a:cs typeface="Arial" pitchFamily="34" charset="-120"/>
               </a:rPr>
-              <a:t>Partner with us. Invest in the infrastructure of Africa's housing journey.</a:t>
+              <a:t>•</a:t>
             </a:r>
             <a:endParaRPr lang="en-US" sz="1100" dirty="0"/>
           </a:p>
@@ -13144,63 +13063,46 @@
       </p:sp>
       <p:sp>
         <p:nvSpPr>
-          <p:cNvPr id="20" name="Text 18"/>
-          <p:cNvSpPr/>
-          <p:nvPr/>
-        </p:nvSpPr>
-        <p:spPr>
-          <a:xfrm>
-            <a:off x="502920" y="3749040"/>
-            <a:ext cx="8138160" cy="502920"/>
-          </a:xfrm>
-          <a:prstGeom prst="rect">
-            <a:avLst/>
-          </a:prstGeom>
-          <a:noFill/>
-          <a:ln/>
-        </p:spPr>
-        <p:txBody>
-          <a:bodyPr wrap="square" rtlCol="0" anchor="ctr"/>
-          <a:lstStyle/>
-          <a:p>
-            <a:pPr algn="ctr" indent="0" marL="0">
-              <a:buNone/>
-            </a:pPr>
-            <a:r>
-              <a:rPr lang="en-US" sz="1000" dirty="0">
-                <a:solidFill>
-                  <a:srgbClr val="5B6C77"/>
-                </a:solidFill>
-                <a:latin typeface="Arial" pitchFamily="34" charset="0"/>
-                <a:ea typeface="Arial" pitchFamily="34" charset="-122"/>
-                <a:cs typeface="Arial" pitchFamily="34" charset="-120"/>
-              </a:rPr>
-              <a:t>NyumbaSearch  ·  nyumbasearch.com  ·  August 2026</a:t>
-            </a:r>
-            <a:endParaRPr lang="en-US" sz="1000" dirty="0"/>
-          </a:p>
-          <a:p>
-            <a:pPr algn="ctr" indent="0" marL="0">
-              <a:buNone/>
-            </a:pPr>
-            <a:r>
-              <a:rPr lang="en-US" sz="1000" dirty="0">
-                <a:solidFill>
-                  <a:srgbClr val="5B6C77"/>
-                </a:solidFill>
-                <a:latin typeface="Arial" pitchFamily="34" charset="0"/>
-                <a:ea typeface="Arial" pitchFamily="34" charset="-122"/>
-                <a:cs typeface="Arial" pitchFamily="34" charset="-120"/>
-              </a:rPr>
-              <a:t>Less stress. Better homes. Stronger communities.</a:t>
-            </a:r>
-            <a:endParaRPr lang="en-US" sz="1000" dirty="0"/>
-          </a:p>
-        </p:txBody>
-      </p:sp>
-      <p:sp>
-        <p:nvSpPr>
-          <p:cNvPr id="21" name="Text 19"/>
+          <p:cNvPr id="19" name="Text 16"/>
+          <p:cNvSpPr/>
+          <p:nvPr/>
+        </p:nvSpPr>
+        <p:spPr>
+          <a:xfrm>
+            <a:off x="1051560" y="3904488"/>
+            <a:ext cx="4114800" cy="292608"/>
+          </a:xfrm>
+          <a:prstGeom prst="rect">
+            <a:avLst/>
+          </a:prstGeom>
+          <a:noFill/>
+          <a:ln/>
+        </p:spPr>
+        <p:txBody>
+          <a:bodyPr wrap="square" rtlCol="0" anchor="ctr"/>
+          <a:lstStyle/>
+          <a:p>
+            <a:pPr indent="0" marL="0">
+              <a:buNone/>
+            </a:pPr>
+            <a:r>
+              <a:rPr lang="en-US" sz="1200" dirty="0">
+                <a:solidFill>
+                  <a:srgbClr val="FAFCFA"/>
+                </a:solidFill>
+                <a:latin typeface="Arial" pitchFamily="34" charset="0"/>
+                <a:ea typeface="Arial" pitchFamily="34" charset="-122"/>
+                <a:cs typeface="Arial" pitchFamily="34" charset="-120"/>
+              </a:rPr>
+              <a:t>Nairobi, Kenya</a:t>
+            </a:r>
+            <a:endParaRPr lang="en-US" sz="1200" dirty="0"/>
+          </a:p>
+        </p:txBody>
+      </p:sp>
+      <p:sp>
+        <p:nvSpPr>
+          <p:cNvPr id="20" name="Text 17"/>
           <p:cNvSpPr/>
           <p:nvPr/>
         </p:nvSpPr>
@@ -13239,7 +13141,7 @@
       </p:sp>
       <p:sp>
         <p:nvSpPr>
-          <p:cNvPr id="22" name="Text 20"/>
+          <p:cNvPr id="21" name="Text 18"/>
           <p:cNvSpPr/>
           <p:nvPr/>
         </p:nvSpPr>

</xml_diff>